<commit_message>
Update presentation deck and final files
</commit_message>
<xml_diff>
--- a/PPT.pptx
+++ b/PPT.pptx
@@ -22707,7 +22707,7 @@
         <p:spPr>
           <a:xfrm>
             <a:off x="605327" y="654603"/>
-            <a:ext cx="8114927" cy="4712851"/>
+            <a:ext cx="8647024" cy="4712851"/>
           </a:xfrm>
           <a:prstGeom prst="rect">
             <a:avLst/>
@@ -22834,7 +22834,7 @@
           <a:p>
             <a:r>
               <a:rPr lang="en-US" sz="1600" dirty="0"/>
-              <a:t>GitHub Repository - [Insert GitHub Link]</a:t>
+              <a:t>GitHub Repository – https://github.com/Harshith422/Neostats_Casestudy</a:t>
             </a:r>
           </a:p>
           <a:p>
@@ -22848,18 +22848,14 @@
             </a:r>
             <a:r>
               <a:rPr lang="en-US" sz="1600" dirty="0"/>
-              <a:t> Cloud) - [Insert </a:t>
+              <a:t> Cloud) – </a:t>
             </a:r>
             <a:r>
-              <a:rPr lang="en-US" sz="1600" dirty="0" err="1"/>
-              <a:t>Streamlit</a:t>
+              <a:rPr lang="en-US" sz="1600" dirty="0">
+                <a:hlinkClick r:id="rId3"/>
+              </a:rPr>
+              <a:t>Click Here</a:t>
             </a:r>
-            <a:r>
-              <a:rPr lang="en-US" sz="1600" dirty="0"/>
-              <a:t> Link]</a:t>
-            </a:r>
-          </a:p>
-          <a:p>
             <a:endParaRPr lang="en-IN" sz="1600" dirty="0"/>
           </a:p>
         </p:txBody>

</xml_diff>